<commit_message>
Fix two layout defects in the conference deck
A slide-by-slide visual pass found two problems.

The square marker on a label row was centred vertically in the row while its
label was top-aligned, so on slides 3 and 9 the square sat visibly below the
text it belonged to. The marker now aligns with the label's first line.

Six slides -- 5, 7, 9, 11, 15 and 17 -- ended their content around two thirds
of the way down and left an empty band beneath. Table row heights, card heights
and body sizes are raised so each column reaches roughly the same depth, with
the footnote below it. Nothing was added or removed; only the vertical rhythm
changed.

Also closes a gap inside the disclosed-deviation card on slide 9, where the
second paragraph was pinned low enough to read as a hole.

deck_overview_*.png are labelled contact sheets of all 18 slides, kept for
review.

Co-Authored-By: Claude Opus 5 <noreply@anthropic.com>
</commit_message>
<xml_diff>
--- a/slides/iwbis_channel_aware_backdoor.pptx
+++ b/slides/iwbis_channel_aware_backdoor.pptx
@@ -4622,7 +4622,7 @@
                 <a:gridCol w="1645920"/>
                 <a:gridCol w="1645920"/>
               </a:tblGrid>
-              <a:tr h="384048">
+              <a:tr h="512064">
                 <a:tc>
                   <a:txBody>
                     <a:bodyPr/>
@@ -4896,7 +4896,7 @@
                   </a:tcPr>
                 </a:tc>
               </a:tr>
-              <a:tr h="384048">
+              <a:tr h="512064">
                 <a:tc>
                   <a:txBody>
                     <a:bodyPr/>
@@ -5170,7 +5170,7 @@
                   </a:tcPr>
                 </a:tc>
               </a:tr>
-              <a:tr h="384048">
+              <a:tr h="512064">
                 <a:tc>
                   <a:txBody>
                     <a:bodyPr/>
@@ -5444,7 +5444,7 @@
                   </a:tcPr>
                 </a:tc>
               </a:tr>
-              <a:tr h="384048">
+              <a:tr h="512064">
                 <a:tc>
                   <a:txBody>
                     <a:bodyPr/>
@@ -5718,7 +5718,7 @@
                   </a:tcPr>
                 </a:tc>
               </a:tr>
-              <a:tr h="384048">
+              <a:tr h="512064">
                 <a:tc>
                   <a:txBody>
                     <a:bodyPr/>
@@ -5992,7 +5992,7 @@
                   </a:tcPr>
                 </a:tc>
               </a:tr>
-              <a:tr h="384048">
+              <a:tr h="512064">
                 <a:tc>
                   <a:txBody>
                     <a:bodyPr/>
@@ -6278,8 +6278,8 @@
         </p:nvSpPr>
         <p:spPr>
           <a:xfrm>
-            <a:off x="8503920" y="1783080"/>
-            <a:ext cx="3017520" cy="2103120"/>
+            <a:off x="8503920" y="1828800"/>
+            <a:ext cx="3017520" cy="2286000"/>
           </a:xfrm>
           <a:prstGeom prst="rect">
             <a:avLst/>
@@ -6293,12 +6293,12 @@
           <a:p>
             <a:pPr indent="0" marL="0">
               <a:lnSpc>
-                <a:spcPts val="1800"/>
+                <a:spcPts val="1900"/>
               </a:lnSpc>
               <a:buNone/>
             </a:pPr>
             <a:r>
-              <a:rPr lang="en-US" sz="1300" dirty="0">
+              <a:rPr lang="en-US" sz="1350" dirty="0">
                 <a:solidFill>
                   <a:srgbClr val="1B2A41"/>
                 </a:solidFill>
@@ -6308,7 +6308,7 @@
               </a:rPr>
               <a:t>Multi-Krum is the only defense that moved the attack at all, so it is the one carried to the multi-seed stage — even though under blue/fusion it too leaves the backdoor at 15 of 15.</a:t>
             </a:r>
-            <a:endParaRPr lang="en-US" sz="1300" dirty="0"/>
+            <a:endParaRPr lang="en-US" sz="1350" dirty="0"/>
           </a:p>
         </p:txBody>
       </p:sp>
@@ -6320,7 +6320,7 @@
         </p:nvSpPr>
         <p:spPr>
           <a:xfrm>
-            <a:off x="640080" y="4526280"/>
+            <a:off x="640080" y="5257800"/>
             <a:ext cx="10881360" cy="640080"/>
           </a:xfrm>
           <a:prstGeom prst="rect">
@@ -8102,7 +8102,7 @@
                 <a:gridCol w="1097280"/>
                 <a:gridCol w="2011680"/>
               </a:tblGrid>
-              <a:tr h="329184">
+              <a:tr h="457200">
                 <a:tc>
                   <a:txBody>
                     <a:bodyPr/>
@@ -8376,7 +8376,7 @@
                   </a:tcPr>
                 </a:tc>
               </a:tr>
-              <a:tr h="329184">
+              <a:tr h="457200">
                 <a:tc>
                   <a:txBody>
                     <a:bodyPr/>
@@ -8650,7 +8650,7 @@
                   </a:tcPr>
                 </a:tc>
               </a:tr>
-              <a:tr h="329184">
+              <a:tr h="457200">
                 <a:tc>
                   <a:txBody>
                     <a:bodyPr/>
@@ -8924,7 +8924,7 @@
                   </a:tcPr>
                 </a:tc>
               </a:tr>
-              <a:tr h="329184">
+              <a:tr h="457200">
                 <a:tc>
                   <a:txBody>
                     <a:bodyPr/>
@@ -9198,7 +9198,7 @@
                   </a:tcPr>
                 </a:tc>
               </a:tr>
-              <a:tr h="329184">
+              <a:tr h="457200">
                 <a:tc>
                   <a:txBody>
                     <a:bodyPr/>
@@ -9472,7 +9472,7 @@
                   </a:tcPr>
                 </a:tc>
               </a:tr>
-              <a:tr h="329184">
+              <a:tr h="457200">
                 <a:tc>
                   <a:txBody>
                     <a:bodyPr/>
@@ -9746,7 +9746,7 @@
                   </a:tcPr>
                 </a:tc>
               </a:tr>
-              <a:tr h="329184">
+              <a:tr h="457200">
                 <a:tc>
                   <a:txBody>
                     <a:bodyPr/>
@@ -10033,11 +10033,11 @@
         <p:spPr>
           <a:xfrm>
             <a:off x="8321040" y="1737360"/>
-            <a:ext cx="3200400" cy="1188720"/>
+            <a:ext cx="3200400" cy="1280160"/>
           </a:xfrm>
           <a:prstGeom prst="roundRect">
             <a:avLst>
-              <a:gd name="adj" fmla="val 4615"/>
+              <a:gd name="adj" fmla="val 4286"/>
             </a:avLst>
           </a:prstGeom>
           <a:solidFill>
@@ -10054,7 +10054,7 @@
         </p:nvSpPr>
         <p:spPr>
           <a:xfrm>
-            <a:off x="8549640" y="1920240"/>
+            <a:off x="8549640" y="1965960"/>
             <a:ext cx="2743200" cy="384048"/>
           </a:xfrm>
           <a:prstGeom prst="rect">
@@ -10093,7 +10093,7 @@
         </p:nvSpPr>
         <p:spPr>
           <a:xfrm>
-            <a:off x="8549640" y="2322576"/>
+            <a:off x="8549640" y="2377440"/>
             <a:ext cx="2743200" cy="365760"/>
           </a:xfrm>
           <a:prstGeom prst="rect">
@@ -10135,8 +10135,8 @@
         </p:nvSpPr>
         <p:spPr>
           <a:xfrm>
-            <a:off x="8321040" y="3154680"/>
-            <a:ext cx="3200400" cy="1920240"/>
+            <a:off x="8321040" y="3291840"/>
+            <a:ext cx="3200400" cy="2011680"/>
           </a:xfrm>
           <a:prstGeom prst="rect">
             <a:avLst/>
@@ -10159,7 +10159,7 @@
               <a:buChar char="•"/>
             </a:pPr>
             <a:r>
-              <a:rPr lang="en-US" sz="1200" dirty="0">
+              <a:rPr lang="en-US" sz="1250" dirty="0">
                 <a:solidFill>
                   <a:srgbClr val="1B2A41"/>
                 </a:solidFill>
@@ -10169,7 +10169,7 @@
               </a:rPr>
               <a:t>With f = 1 and |S| = 2 of five clients, the poisoned update is not an outlier in parameter space.</a:t>
             </a:r>
-            <a:endParaRPr lang="en-US" sz="1200" dirty="0"/>
+            <a:endParaRPr lang="en-US" sz="1250" dirty="0"/>
           </a:p>
           <a:p>
             <a:pPr marL="342900" indent="-342900">
@@ -10180,7 +10180,7 @@
               <a:buChar char="•"/>
             </a:pPr>
             <a:r>
-              <a:rPr lang="en-US" sz="1200" dirty="0">
+              <a:rPr lang="en-US" sz="1250" dirty="0">
                 <a:solidFill>
                   <a:srgbClr val="1B2A41"/>
                 </a:solidFill>
@@ -10190,7 +10190,7 @@
               </a:rPr>
               <a:t>Surviving selection is close to a coin flip, and the attacker only has to win often enough.</a:t>
             </a:r>
-            <a:endParaRPr lang="en-US" sz="1200" dirty="0"/>
+            <a:endParaRPr lang="en-US" sz="1250" dirty="0"/>
           </a:p>
         </p:txBody>
       </p:sp>
@@ -10202,7 +10202,7 @@
         </p:nvSpPr>
         <p:spPr>
           <a:xfrm>
-            <a:off x="640080" y="5394960"/>
+            <a:off x="640080" y="5532120"/>
             <a:ext cx="10881360" cy="640080"/>
           </a:xfrm>
           <a:prstGeom prst="rect">
@@ -10859,8 +10859,8 @@
         </p:nvSpPr>
         <p:spPr>
           <a:xfrm>
-            <a:off x="640080" y="2057400"/>
-            <a:ext cx="5303520" cy="3017520"/>
+            <a:off x="640080" y="2103120"/>
+            <a:ext cx="5303520" cy="3291840"/>
           </a:xfrm>
           <a:prstGeom prst="rect">
             <a:avLst/>
@@ -10883,7 +10883,7 @@
               <a:buChar char="•"/>
             </a:pPr>
             <a:r>
-              <a:rPr lang="en-US" sz="1350" dirty="0">
+              <a:rPr lang="en-US" sz="1450" dirty="0">
                 <a:solidFill>
                   <a:srgbClr val="1B2A41"/>
                 </a:solidFill>
@@ -10893,7 +10893,7 @@
               </a:rPr>
               <a:t>Blue/fusion and full-RGB triggers reach 15 of 15 across three seeds, with clean performance close to the baseline.</a:t>
             </a:r>
-            <a:endParaRPr lang="en-US" sz="1350" dirty="0"/>
+            <a:endParaRPr lang="en-US" sz="1450" dirty="0"/>
           </a:p>
           <a:p>
             <a:pPr marL="342900" indent="-342900">
@@ -10907,7 +10907,7 @@
               <a:buChar char="•"/>
             </a:pPr>
             <a:r>
-              <a:rPr lang="en-US" sz="1350" dirty="0">
+              <a:rPr lang="en-US" sz="1450" dirty="0">
                 <a:solidFill>
                   <a:srgbClr val="1B2A41"/>
                 </a:solidFill>
@@ -10917,7 +10917,7 @@
               </a:rPr>
               <a:t>In seven of the eight trigger controls the target rate is identical with and without the trigger, so the effect comes from poisoning.</a:t>
             </a:r>
-            <a:endParaRPr lang="en-US" sz="1350" dirty="0"/>
+            <a:endParaRPr lang="en-US" sz="1450" dirty="0"/>
           </a:p>
           <a:p>
             <a:pPr marL="342900" indent="-342900">
@@ -10928,7 +10928,7 @@
               <a:buChar char="•"/>
             </a:pPr>
             <a:r>
-              <a:rPr lang="en-US" sz="1350" dirty="0">
+              <a:rPr lang="en-US" sz="1450" dirty="0">
                 <a:solidFill>
                   <a:srgbClr val="1B2A41"/>
                 </a:solidFill>
@@ -10938,7 +10938,7 @@
               </a:rPr>
               <a:t>Multi-Krum reduces the attack bimodally rather than partially, leaving it fully effective on one of the three seeds for each trigger.</a:t>
             </a:r>
-            <a:endParaRPr lang="en-US" sz="1350" dirty="0"/>
+            <a:endParaRPr lang="en-US" sz="1450" dirty="0"/>
           </a:p>
         </p:txBody>
       </p:sp>
@@ -10989,7 +10989,7 @@
         </p:nvSpPr>
         <p:spPr>
           <a:xfrm>
-            <a:off x="6492240" y="2112264"/>
+            <a:off x="6492240" y="2157984"/>
             <a:ext cx="201168" cy="201168"/>
           </a:xfrm>
           <a:prstGeom prst="rect">
@@ -11009,7 +11009,7 @@
         </p:nvSpPr>
         <p:spPr>
           <a:xfrm>
-            <a:off x="6858000" y="2057400"/>
+            <a:off x="6858000" y="2103120"/>
             <a:ext cx="4663440" cy="274320"/>
           </a:xfrm>
           <a:prstGeom prst="rect">
@@ -11048,7 +11048,7 @@
         </p:nvSpPr>
         <p:spPr>
           <a:xfrm>
-            <a:off x="6858000" y="2331720"/>
+            <a:off x="6858000" y="2377440"/>
             <a:ext cx="4663440" cy="411480"/>
           </a:xfrm>
           <a:prstGeom prst="rect">
@@ -11090,7 +11090,7 @@
         </p:nvSpPr>
         <p:spPr>
           <a:xfrm>
-            <a:off x="6492240" y="2871216"/>
+            <a:off x="6492240" y="3026664"/>
             <a:ext cx="201168" cy="201168"/>
           </a:xfrm>
           <a:prstGeom prst="rect">
@@ -11110,7 +11110,7 @@
         </p:nvSpPr>
         <p:spPr>
           <a:xfrm>
-            <a:off x="6858000" y="2816352"/>
+            <a:off x="6858000" y="2971800"/>
             <a:ext cx="4663440" cy="274320"/>
           </a:xfrm>
           <a:prstGeom prst="rect">
@@ -11149,7 +11149,7 @@
         </p:nvSpPr>
         <p:spPr>
           <a:xfrm>
-            <a:off x="6858000" y="3090672"/>
+            <a:off x="6858000" y="3246120"/>
             <a:ext cx="4663440" cy="411480"/>
           </a:xfrm>
           <a:prstGeom prst="rect">
@@ -11191,7 +11191,7 @@
         </p:nvSpPr>
         <p:spPr>
           <a:xfrm>
-            <a:off x="6492240" y="3630168"/>
+            <a:off x="6492240" y="3895344"/>
             <a:ext cx="201168" cy="201168"/>
           </a:xfrm>
           <a:prstGeom prst="rect">
@@ -11211,7 +11211,7 @@
         </p:nvSpPr>
         <p:spPr>
           <a:xfrm>
-            <a:off x="6858000" y="3575304"/>
+            <a:off x="6858000" y="3840480"/>
             <a:ext cx="4663440" cy="274320"/>
           </a:xfrm>
           <a:prstGeom prst="rect">
@@ -11250,7 +11250,7 @@
         </p:nvSpPr>
         <p:spPr>
           <a:xfrm>
-            <a:off x="6858000" y="3849624"/>
+            <a:off x="6858000" y="4114800"/>
             <a:ext cx="4663440" cy="411480"/>
           </a:xfrm>
           <a:prstGeom prst="rect">
@@ -11292,7 +11292,7 @@
         </p:nvSpPr>
         <p:spPr>
           <a:xfrm>
-            <a:off x="6492240" y="4389120"/>
+            <a:off x="6492240" y="4764024"/>
             <a:ext cx="201168" cy="201168"/>
           </a:xfrm>
           <a:prstGeom prst="rect">
@@ -11312,7 +11312,7 @@
         </p:nvSpPr>
         <p:spPr>
           <a:xfrm>
-            <a:off x="6858000" y="4334256"/>
+            <a:off x="6858000" y="4709160"/>
             <a:ext cx="4663440" cy="274320"/>
           </a:xfrm>
           <a:prstGeom prst="rect">
@@ -11351,7 +11351,7 @@
         </p:nvSpPr>
         <p:spPr>
           <a:xfrm>
-            <a:off x="6858000" y="4608576"/>
+            <a:off x="6858000" y="4983480"/>
             <a:ext cx="4663440" cy="411480"/>
           </a:xfrm>
           <a:prstGeom prst="rect">
@@ -11393,7 +11393,7 @@
         </p:nvSpPr>
         <p:spPr>
           <a:xfrm>
-            <a:off x="640080" y="5440680"/>
+            <a:off x="640080" y="5623560"/>
             <a:ext cx="10881360" cy="640080"/>
           </a:xfrm>
           <a:prstGeom prst="rect">
@@ -12949,7 +12949,7 @@
         </p:nvSpPr>
         <p:spPr>
           <a:xfrm>
-            <a:off x="914400" y="2176272"/>
+            <a:off x="914400" y="1956816"/>
             <a:ext cx="219456" cy="219456"/>
           </a:xfrm>
           <a:prstGeom prst="rect">
@@ -13072,7 +13072,7 @@
         </p:nvSpPr>
         <p:spPr>
           <a:xfrm>
-            <a:off x="914400" y="3383280"/>
+            <a:off x="914400" y="3163824"/>
             <a:ext cx="219456" cy="219456"/>
           </a:xfrm>
           <a:prstGeom prst="rect">
@@ -13195,7 +13195,7 @@
         </p:nvSpPr>
         <p:spPr>
           <a:xfrm>
-            <a:off x="914400" y="4590288"/>
+            <a:off x="914400" y="4370832"/>
             <a:ext cx="219456" cy="219456"/>
           </a:xfrm>
           <a:prstGeom prst="rect">
@@ -14248,7 +14248,7 @@
                 <a:gridCol w="960120"/>
                 <a:gridCol w="960120"/>
               </a:tblGrid>
-              <a:tr h="329184">
+              <a:tr h="457200">
                 <a:tc>
                   <a:txBody>
                     <a:bodyPr/>
@@ -14590,7 +14590,7 @@
                   </a:tcPr>
                 </a:tc>
               </a:tr>
-              <a:tr h="329184">
+              <a:tr h="457200">
                 <a:tc>
                   <a:txBody>
                     <a:bodyPr/>
@@ -14932,7 +14932,7 @@
                   </a:tcPr>
                 </a:tc>
               </a:tr>
-              <a:tr h="329184">
+              <a:tr h="457200">
                 <a:tc>
                   <a:txBody>
                     <a:bodyPr/>
@@ -15274,7 +15274,7 @@
                   </a:tcPr>
                 </a:tc>
               </a:tr>
-              <a:tr h="329184">
+              <a:tr h="457200">
                 <a:tc>
                   <a:txBody>
                     <a:bodyPr/>
@@ -15616,7 +15616,7 @@
                   </a:tcPr>
                 </a:tc>
               </a:tr>
-              <a:tr h="329184">
+              <a:tr h="457200">
                 <a:tc>
                   <a:txBody>
                     <a:bodyPr/>
@@ -15958,7 +15958,7 @@
                   </a:tcPr>
                 </a:tc>
               </a:tr>
-              <a:tr h="329184">
+              <a:tr h="457200">
                 <a:tc>
                   <a:txBody>
                     <a:bodyPr/>
@@ -16300,7 +16300,7 @@
                   </a:tcPr>
                 </a:tc>
               </a:tr>
-              <a:tr h="329184">
+              <a:tr h="457200">
                 <a:tc>
                   <a:txBody>
                     <a:bodyPr/>
@@ -16654,8 +16654,8 @@
         </p:nvSpPr>
         <p:spPr>
           <a:xfrm>
-            <a:off x="6949440" y="1783080"/>
-            <a:ext cx="4572000" cy="2743200"/>
+            <a:off x="6949440" y="1828800"/>
+            <a:ext cx="4572000" cy="3108960"/>
           </a:xfrm>
           <a:prstGeom prst="rect">
             <a:avLst/>
@@ -16678,7 +16678,7 @@
               <a:buChar char="•"/>
             </a:pPr>
             <a:r>
-              <a:rPr lang="en-US" sz="1350" dirty="0">
+              <a:rPr lang="en-US" sz="1450" dirty="0">
                 <a:solidFill>
                   <a:srgbClr val="1B2A41"/>
                 </a:solidFill>
@@ -16688,7 +16688,7 @@
               </a:rPr>
               <a:t>Cuckoo Sandbox traces become a 16 x 16 API tile; packet captures become a 28 x 28 network tile.</a:t>
             </a:r>
-            <a:endParaRPr lang="en-US" sz="1350" dirty="0"/>
+            <a:endParaRPr lang="en-US" sz="1450" dirty="0"/>
           </a:p>
           <a:p>
             <a:pPr marL="342900" indent="-342900">
@@ -16702,7 +16702,7 @@
               <a:buChar char="•"/>
             </a:pPr>
             <a:r>
-              <a:rPr lang="en-US" sz="1350" dirty="0">
+              <a:rPr lang="en-US" sz="1450" dirty="0">
                 <a:solidFill>
                   <a:srgbClr val="1B2A41"/>
                 </a:solidFill>
@@ -16712,7 +16712,7 @@
               </a:rPr>
               <a:t>Only the largest-payload session per sample is kept, to limit sample-level leakage.</a:t>
             </a:r>
-            <a:endParaRPr lang="en-US" sz="1350" dirty="0"/>
+            <a:endParaRPr lang="en-US" sz="1450" dirty="0"/>
           </a:p>
           <a:p>
             <a:pPr marL="342900" indent="-342900">
@@ -16723,7 +16723,7 @@
               <a:buChar char="•"/>
             </a:pPr>
             <a:r>
-              <a:rPr lang="en-US" sz="1350" dirty="0">
+              <a:rPr lang="en-US" sz="1450" dirty="0">
                 <a:solidFill>
                   <a:srgbClr val="1B2A41"/>
                 </a:solidFill>
@@ -16733,7 +16733,7 @@
               </a:rPr>
               <a:t>Stratified by family and re-drawn for every seed, so the seeds do not share a test set.</a:t>
             </a:r>
-            <a:endParaRPr lang="en-US" sz="1350" dirty="0"/>
+            <a:endParaRPr lang="en-US" sz="1450" dirty="0"/>
           </a:p>
         </p:txBody>
       </p:sp>
@@ -16745,7 +16745,7 @@
         </p:nvSpPr>
         <p:spPr>
           <a:xfrm>
-            <a:off x="640080" y="4572000"/>
+            <a:off x="640080" y="5303520"/>
             <a:ext cx="10881360" cy="640080"/>
           </a:xfrm>
           <a:prstGeom prst="rect">
@@ -17728,7 +17728,7 @@
                 <a:gridCol w="1325880"/>
                 <a:gridCol w="1325880"/>
               </a:tblGrid>
-              <a:tr h="329184">
+              <a:tr h="457200">
                 <a:tc>
                   <a:txBody>
                     <a:bodyPr/>
@@ -18002,7 +18002,7 @@
                   </a:tcPr>
                 </a:tc>
               </a:tr>
-              <a:tr h="329184">
+              <a:tr h="457200">
                 <a:tc>
                   <a:txBody>
                     <a:bodyPr/>
@@ -18276,7 +18276,7 @@
                   </a:tcPr>
                 </a:tc>
               </a:tr>
-              <a:tr h="329184">
+              <a:tr h="457200">
                 <a:tc>
                   <a:txBody>
                     <a:bodyPr/>
@@ -18550,7 +18550,7 @@
                   </a:tcPr>
                 </a:tc>
               </a:tr>
-              <a:tr h="329184">
+              <a:tr h="457200">
                 <a:tc>
                   <a:txBody>
                     <a:bodyPr/>
@@ -18824,7 +18824,7 @@
                   </a:tcPr>
                 </a:tc>
               </a:tr>
-              <a:tr h="329184">
+              <a:tr h="457200">
                 <a:tc>
                   <a:txBody>
                     <a:bodyPr/>
@@ -19098,7 +19098,7 @@
                   </a:tcPr>
                 </a:tc>
               </a:tr>
-              <a:tr h="329184">
+              <a:tr h="457200">
                 <a:tc>
                   <a:txBody>
                     <a:bodyPr/>
@@ -19372,7 +19372,7 @@
                   </a:tcPr>
                 </a:tc>
               </a:tr>
-              <a:tr h="329184">
+              <a:tr h="457200">
                 <a:tc>
                   <a:txBody>
                     <a:bodyPr/>
@@ -19659,11 +19659,11 @@
         <p:spPr>
           <a:xfrm>
             <a:off x="7635240" y="1783080"/>
-            <a:ext cx="3886200" cy="2286000"/>
+            <a:ext cx="3886200" cy="3200400"/>
           </a:xfrm>
           <a:prstGeom prst="roundRect">
             <a:avLst>
-              <a:gd name="adj" fmla="val 2400"/>
+              <a:gd name="adj" fmla="val 1714"/>
             </a:avLst>
           </a:prstGeom>
           <a:solidFill>
@@ -19680,7 +19680,7 @@
         </p:nvSpPr>
         <p:spPr>
           <a:xfrm>
-            <a:off x="7909560" y="1947672"/>
+            <a:off x="7909560" y="2011680"/>
             <a:ext cx="3337560" cy="274320"/>
           </a:xfrm>
           <a:prstGeom prst="rect">
@@ -19719,7 +19719,7 @@
         </p:nvSpPr>
         <p:spPr>
           <a:xfrm>
-            <a:off x="7909560" y="2304288"/>
+            <a:off x="7909560" y="2514600"/>
             <a:ext cx="1234440" cy="274320"/>
           </a:xfrm>
           <a:prstGeom prst="rect">
@@ -19758,7 +19758,7 @@
         </p:nvSpPr>
         <p:spPr>
           <a:xfrm>
-            <a:off x="9189720" y="2304288"/>
+            <a:off x="9189720" y="2514600"/>
             <a:ext cx="2103120" cy="502920"/>
           </a:xfrm>
           <a:prstGeom prst="rect">
@@ -19800,7 +19800,7 @@
         </p:nvSpPr>
         <p:spPr>
           <a:xfrm>
-            <a:off x="7909560" y="2852928"/>
+            <a:off x="7909560" y="3264408"/>
             <a:ext cx="1234440" cy="274320"/>
           </a:xfrm>
           <a:prstGeom prst="rect">
@@ -19839,7 +19839,7 @@
         </p:nvSpPr>
         <p:spPr>
           <a:xfrm>
-            <a:off x="9189720" y="2852928"/>
+            <a:off x="9189720" y="3264408"/>
             <a:ext cx="2103120" cy="502920"/>
           </a:xfrm>
           <a:prstGeom prst="rect">
@@ -19881,7 +19881,7 @@
         </p:nvSpPr>
         <p:spPr>
           <a:xfrm>
-            <a:off x="7909560" y="3401568"/>
+            <a:off x="7909560" y="4014216"/>
             <a:ext cx="1234440" cy="274320"/>
           </a:xfrm>
           <a:prstGeom prst="rect">
@@ -19920,7 +19920,7 @@
         </p:nvSpPr>
         <p:spPr>
           <a:xfrm>
-            <a:off x="9189720" y="3401568"/>
+            <a:off x="9189720" y="4014216"/>
             <a:ext cx="2103120" cy="502920"/>
           </a:xfrm>
           <a:prstGeom prst="rect">
@@ -19962,7 +19962,7 @@
         </p:nvSpPr>
         <p:spPr>
           <a:xfrm>
-            <a:off x="640080" y="4434840"/>
+            <a:off x="640080" y="5303520"/>
             <a:ext cx="10881360" cy="640080"/>
           </a:xfrm>
           <a:prstGeom prst="rect">
@@ -20960,11 +20960,11 @@
         <p:spPr>
           <a:xfrm>
             <a:off x="640080" y="1783080"/>
-            <a:ext cx="7132320" cy="868680"/>
+            <a:ext cx="7132320" cy="987552"/>
           </a:xfrm>
           <a:prstGeom prst="roundRect">
             <a:avLst>
-              <a:gd name="adj" fmla="val 6316"/>
+              <a:gd name="adj" fmla="val 5556"/>
             </a:avLst>
           </a:prstGeom>
           <a:solidFill>
@@ -20981,7 +20981,7 @@
         </p:nvSpPr>
         <p:spPr>
           <a:xfrm>
-            <a:off x="914400" y="2107692"/>
+            <a:off x="914400" y="1956816"/>
             <a:ext cx="219456" cy="219456"/>
           </a:xfrm>
           <a:prstGeom prst="rect">
@@ -21002,7 +21002,7 @@
         <p:spPr>
           <a:xfrm>
             <a:off x="1325880" y="1947672"/>
-            <a:ext cx="1737360" cy="594360"/>
+            <a:ext cx="1737360" cy="713232"/>
           </a:xfrm>
           <a:prstGeom prst="rect">
             <a:avLst/>
@@ -21041,7 +21041,7 @@
         <p:spPr>
           <a:xfrm>
             <a:off x="3291840" y="1947672"/>
-            <a:ext cx="4251960" cy="594360"/>
+            <a:ext cx="4251960" cy="713232"/>
           </a:xfrm>
           <a:prstGeom prst="rect">
             <a:avLst/>
@@ -21082,12 +21082,12 @@
         </p:nvSpPr>
         <p:spPr>
           <a:xfrm>
-            <a:off x="640080" y="2834640"/>
-            <a:ext cx="7132320" cy="868680"/>
+            <a:off x="640080" y="2953512"/>
+            <a:ext cx="7132320" cy="987552"/>
           </a:xfrm>
           <a:prstGeom prst="roundRect">
             <a:avLst>
-              <a:gd name="adj" fmla="val 6316"/>
+              <a:gd name="adj" fmla="val 5556"/>
             </a:avLst>
           </a:prstGeom>
           <a:solidFill>
@@ -21104,7 +21104,7 @@
         </p:nvSpPr>
         <p:spPr>
           <a:xfrm>
-            <a:off x="914400" y="3159252"/>
+            <a:off x="914400" y="3127248"/>
             <a:ext cx="219456" cy="219456"/>
           </a:xfrm>
           <a:prstGeom prst="rect">
@@ -21124,8 +21124,8 @@
         </p:nvSpPr>
         <p:spPr>
           <a:xfrm>
-            <a:off x="1325880" y="2999232"/>
-            <a:ext cx="1737360" cy="594360"/>
+            <a:off x="1325880" y="3118104"/>
+            <a:ext cx="1737360" cy="713232"/>
           </a:xfrm>
           <a:prstGeom prst="rect">
             <a:avLst/>
@@ -21163,8 +21163,8 @@
         </p:nvSpPr>
         <p:spPr>
           <a:xfrm>
-            <a:off x="3291840" y="2999232"/>
-            <a:ext cx="4251960" cy="594360"/>
+            <a:off x="3291840" y="3118104"/>
+            <a:ext cx="4251960" cy="713232"/>
           </a:xfrm>
           <a:prstGeom prst="rect">
             <a:avLst/>
@@ -21205,12 +21205,12 @@
         </p:nvSpPr>
         <p:spPr>
           <a:xfrm>
-            <a:off x="640080" y="3886200"/>
-            <a:ext cx="7132320" cy="868680"/>
+            <a:off x="640080" y="4123944"/>
+            <a:ext cx="7132320" cy="987552"/>
           </a:xfrm>
           <a:prstGeom prst="roundRect">
             <a:avLst>
-              <a:gd name="adj" fmla="val 6316"/>
+              <a:gd name="adj" fmla="val 5556"/>
             </a:avLst>
           </a:prstGeom>
           <a:solidFill>
@@ -21227,7 +21227,7 @@
         </p:nvSpPr>
         <p:spPr>
           <a:xfrm>
-            <a:off x="914400" y="4210812"/>
+            <a:off x="914400" y="4297680"/>
             <a:ext cx="219456" cy="219456"/>
           </a:xfrm>
           <a:prstGeom prst="rect">
@@ -21247,8 +21247,8 @@
         </p:nvSpPr>
         <p:spPr>
           <a:xfrm>
-            <a:off x="1325880" y="4050792"/>
-            <a:ext cx="1737360" cy="594360"/>
+            <a:off x="1325880" y="4288536"/>
+            <a:ext cx="1737360" cy="713232"/>
           </a:xfrm>
           <a:prstGeom prst="rect">
             <a:avLst/>
@@ -21286,8 +21286,8 @@
         </p:nvSpPr>
         <p:spPr>
           <a:xfrm>
-            <a:off x="3291840" y="4050792"/>
-            <a:ext cx="4251960" cy="594360"/>
+            <a:off x="3291840" y="4288536"/>
+            <a:ext cx="4251960" cy="713232"/>
           </a:xfrm>
           <a:prstGeom prst="rect">
             <a:avLst/>
@@ -21329,11 +21329,11 @@
         <p:spPr>
           <a:xfrm>
             <a:off x="8092440" y="1783080"/>
-            <a:ext cx="3429000" cy="3063240"/>
+            <a:ext cx="3429000" cy="3511296"/>
           </a:xfrm>
           <a:prstGeom prst="roundRect">
             <a:avLst>
-              <a:gd name="adj" fmla="val 1791"/>
+              <a:gd name="adj" fmla="val 1600"/>
             </a:avLst>
           </a:prstGeom>
           <a:solidFill>
@@ -21350,7 +21350,7 @@
         </p:nvSpPr>
         <p:spPr>
           <a:xfrm>
-            <a:off x="8366760" y="1965960"/>
+            <a:off x="8366760" y="2011680"/>
             <a:ext cx="2880360" cy="274320"/>
           </a:xfrm>
           <a:prstGeom prst="rect">
@@ -21389,7 +21389,7 @@
         </p:nvSpPr>
         <p:spPr>
           <a:xfrm>
-            <a:off x="8366760" y="2331720"/>
+            <a:off x="8366760" y="2395728"/>
             <a:ext cx="2880360" cy="1188720"/>
           </a:xfrm>
           <a:prstGeom prst="rect">
@@ -21431,8 +21431,8 @@
         </p:nvSpPr>
         <p:spPr>
           <a:xfrm>
-            <a:off x="8366760" y="3611880"/>
-            <a:ext cx="2880360" cy="1005840"/>
+            <a:off x="8366760" y="3794760"/>
+            <a:ext cx="2880360" cy="1097280"/>
           </a:xfrm>
           <a:prstGeom prst="rect">
             <a:avLst/>
@@ -21473,7 +21473,7 @@
         </p:nvSpPr>
         <p:spPr>
           <a:xfrm>
-            <a:off x="640080" y="5120640"/>
+            <a:off x="640080" y="5532120"/>
             <a:ext cx="10881360" cy="640080"/>
           </a:xfrm>
           <a:prstGeom prst="rect">

</xml_diff>